<commit_message>
Unify prior-patent wording, goal labels, and step colors
Use 先行特許 throughout, label process outcomes as ゴール, and make
all step numbers on the overview slide the same navy.

Co-authored-by: zhexingwang <zhexingwang@users.noreply.github.com>
</commit_message>
<xml_diff>
--- a/decks/05_Copilot発明開示書/Copilot発明開示書_訂正反映.pptx
+++ b/decks/05_Copilot発明開示書/Copilot発明開示書_訂正反映.pptx
@@ -3260,7 +3260,7 @@
                 </a:solidFill>
                 <a:latin typeface="Noto Sans CJK JP"/>
               </a:rPr>
-              <a:t>ゼロから素案まで　─　先行調査を先に、クレームは後で</a:t>
+              <a:t>ゼロから素案まで　─　先行特許調査を先に、クレームは後で</a:t>
             </a:r>
           </a:p>
         </p:txBody>
@@ -4177,7 +4177,7 @@
                 </a:solidFill>
                 <a:latin typeface="Noto Sans CJK JP"/>
               </a:rPr>
-              <a:t>やること 1　先行の要約を入力する</a:t>
+              <a:t>やること 1　先行特許の要約を入力する</a:t>
             </a:r>
           </a:p>
         </p:txBody>
@@ -4502,7 +4502,7 @@
                 </a:solidFill>
                 <a:latin typeface="Noto Sans CJK JP"/>
               </a:rPr>
-              <a:t>先行は「ルールでロジックを自動生成するが、SIL検証と変更追跡はない」とします。本発明との差を、従来／課題／差／優位性の表にしてください。差が弱い欄も指摘してください。</a:t>
+              <a:t>先行特許は「ルールでロジックを自動生成するが、SIL検証と変更追跡はない」とします。本発明との差を、従来／課題／差／優位性の表にしてください。差が弱い欄も指摘してください。</a:t>
             </a:r>
           </a:p>
         </p:txBody>
@@ -4717,7 +4717,7 @@
                 </a:solidFill>
                 <a:latin typeface="Noto Sans CJK JP"/>
               </a:rPr>
-              <a:t>■ 差が弱い欄　『自動生成すること自体』『ルールベースであること』は先行と重なりやすい。クレームの核にしない。核は『検証結果の設計への反映』と『入力項目と素子の対応の記録』に置く。</a:t>
+              <a:t>■ 差が弱い欄　『自動生成すること自体』『ルールベースであること』は先行特許と重なりやすい。クレームの核にしない。核は『検証結果の設計への反映』と『入力項目と素子の対応の記録』に置く。</a:t>
             </a:r>
           </a:p>
         </p:txBody>
@@ -5509,7 +5509,7 @@
                 </a:solidFill>
                 <a:latin typeface="Noto Sans CJK JP"/>
               </a:rPr>
-              <a:t>先行と被りにくい保護範囲の案がある</a:t>
+              <a:t>先行特許と被りにくい保護範囲の案がある</a:t>
             </a:r>
           </a:p>
         </p:txBody>
@@ -5994,7 +5994,7 @@
                 </a:solidFill>
                 <a:latin typeface="Noto Sans CJK JP"/>
               </a:rPr>
-              <a:t>上の差を踏まえ、先行と被りにくい独立クレームの骨格と、従属クレーム・発展例の案を作ってください。独立項が『自動生成』だけで終わらないようにしてください。</a:t>
+              <a:t>上の差を踏まえ、先行特許と被りにくい独立クレームの骨格と、従属クレーム・発展例の案を作ってください。独立項が『自動生成』だけで終わらないようにしてください。</a:t>
             </a:r>
           </a:p>
         </p:txBody>
@@ -6114,7 +6114,7 @@
                 </a:solidFill>
                 <a:latin typeface="Noto Sans CJK JP"/>
               </a:rPr>
-              <a:t>独立項は差の核だけにします。『ロジックを自動生成する手段』だけで始めると、Step 1で見た先行に被りやすいです。</a:t>
+              <a:t>独立項は差の核だけにします。『ロジックを自動生成する手段』だけで始めると、Step 1で見た先行特許に被りやすいです。</a:t>
             </a:r>
           </a:p>
           <a:p>
@@ -9269,7 +9269,7 @@
                 </a:solidFill>
                 <a:latin typeface="Noto Sans CJK JP"/>
               </a:rPr>
-              <a:t>近い特許を先に見る
+              <a:t>近い先行特許を先に見る
 クレームはそのあとで書く</a:t>
             </a:r>
           </a:p>
@@ -10254,7 +10254,7 @@
                 </a:solidFill>
                 <a:latin typeface="Noto Sans CJK JP"/>
               </a:rPr>
-              <a:t>文章づくりと、近い特許を探すこと</a:t>
+              <a:t>文章づくりと、近い先行特許を探すこと</a:t>
             </a:r>
           </a:p>
         </p:txBody>
@@ -12239,7 +12239,7 @@
                 <a:latin typeface="Noto Sans CJK JP"/>
               </a:rPr>
               <a:t>テンプレート：知的財産部ホームページ（ANAQUA形式）
-クレーム案（5）は、先行調査のあとで書く。</a:t>
+クレーム案（5）は、先行特許調査のあとで書く。</a:t>
             </a:r>
           </a:p>
         </p:txBody>
@@ -12448,7 +12448,7 @@
                 </a:solidFill>
                 <a:latin typeface="Noto Sans CJK JP"/>
               </a:rPr>
-              <a:t>上段がやること。下段の一文ができたら、次のStepへ進んでよい</a:t>
+              <a:t>上段がやること。下段がゴール。ゴールに達したら次へ進む</a:t>
             </a:r>
           </a:p>
         </p:txBody>
@@ -12729,7 +12729,7 @@
                 </a:solidFill>
                 <a:latin typeface="Noto Sans CJK JP"/>
               </a:rPr>
-              <a:t>終わったら</a:t>
+              <a:t>ゴール</a:t>
             </a:r>
           </a:p>
         </p:txBody>
@@ -12865,7 +12865,7 @@
             <a:avLst/>
           </a:prstGeom>
           <a:solidFill>
-            <a:srgbClr val="ED7D31"/>
+            <a:srgbClr val="1F4E79"/>
           </a:solidFill>
           <a:ln>
             <a:noFill/>
@@ -12958,7 +12958,7 @@
                 </a:solidFill>
                 <a:latin typeface="Noto Sans CJK JP"/>
               </a:rPr>
-              <a:t>先行を先に見る</a:t>
+              <a:t>先行特許を先に見る</a:t>
             </a:r>
           </a:p>
         </p:txBody>
@@ -12978,7 +12978,7 @@
             <a:avLst/>
           </a:prstGeom>
           <a:solidFill>
-            <a:srgbClr val="ED7D31"/>
+            <a:srgbClr val="1F4E79"/>
           </a:solidFill>
           <a:ln>
             <a:noFill/>
@@ -13081,7 +13081,7 @@
                 </a:solidFill>
                 <a:latin typeface="Noto Sans CJK JP"/>
               </a:rPr>
-              <a:t>終わったら</a:t>
+              <a:t>ゴール</a:t>
             </a:r>
           </a:p>
         </p:txBody>
@@ -13116,7 +13116,7 @@
                 </a:solidFill>
                 <a:latin typeface="Noto Sans CJK JP"/>
               </a:rPr>
-              <a:t>近い特許と
+              <a:t>近い先行特許と
 被りそうな点が見える</a:t>
             </a:r>
           </a:p>
@@ -13433,7 +13433,7 @@
                 </a:solidFill>
                 <a:latin typeface="Noto Sans CJK JP"/>
               </a:rPr>
-              <a:t>終わったら</a:t>
+              <a:t>ゴール</a:t>
             </a:r>
           </a:p>
         </p:txBody>
@@ -13469,7 +13469,7 @@
                 <a:latin typeface="Noto Sans CJK JP"/>
               </a:rPr>
               <a:t>構成と流れと
-先行にない点が言える</a:t>
+先行特許にない点が言える</a:t>
             </a:r>
           </a:p>
         </p:txBody>
@@ -13785,7 +13785,7 @@
                 </a:solidFill>
                 <a:latin typeface="Noto Sans CJK JP"/>
               </a:rPr>
-              <a:t>終わったら</a:t>
+              <a:t>ゴール</a:t>
             </a:r>
           </a:p>
         </p:txBody>
@@ -13921,7 +13921,7 @@
             <a:avLst/>
           </a:prstGeom>
           <a:solidFill>
-            <a:srgbClr val="ED7D31"/>
+            <a:srgbClr val="1F4E79"/>
           </a:solidFill>
           <a:ln>
             <a:noFill/>
@@ -14034,7 +14034,7 @@
             <a:avLst/>
           </a:prstGeom>
           <a:solidFill>
-            <a:srgbClr val="ED7D31"/>
+            <a:srgbClr val="1F4E79"/>
           </a:solidFill>
           <a:ln>
             <a:noFill/>
@@ -14137,7 +14137,7 @@
                 </a:solidFill>
                 <a:latin typeface="Noto Sans CJK JP"/>
               </a:rPr>
-              <a:t>終わったら</a:t>
+              <a:t>ゴール</a:t>
             </a:r>
           </a:p>
         </p:txBody>
@@ -14489,7 +14489,7 @@
                 </a:solidFill>
                 <a:latin typeface="Noto Sans CJK JP"/>
               </a:rPr>
-              <a:t>終わったら</a:t>
+              <a:t>ゴール</a:t>
             </a:r>
           </a:p>
         </p:txBody>
@@ -17490,7 +17490,7 @@
                 </a:solidFill>
                 <a:latin typeface="Noto Sans CJK JP"/>
               </a:rPr>
-              <a:t>■ 注意　『自動生成』は先行にもよく出ます。生成までで止まっているか、検証結果を設計へ戻しているか、追跡表があるか、を先に見てください。似ている点／違う点が一言で言えたら、Step 2へ進みます。</a:t>
+              <a:t>■ 注意　『自動生成』は先行特許にもよく出ます。生成までで止まっているか、検証結果を設計へ戻しているか、追跡表があるか、を先に見てください。似ている点／違う点が一言で言えたら、Step 2へ進みます。</a:t>
             </a:r>
           </a:p>
         </p:txBody>
@@ -18282,7 +18282,7 @@
                 </a:solidFill>
                 <a:latin typeface="Noto Sans CJK JP"/>
               </a:rPr>
-              <a:t>構成・処理の流れ・先行にない点が説明できる</a:t>
+              <a:t>構成・処理の流れ・先行特許にない点が説明できる</a:t>
             </a:r>
           </a:p>
         </p:txBody>
@@ -18362,7 +18362,7 @@
                 </a:solidFill>
                 <a:latin typeface="Noto Sans CJK JP"/>
               </a:rPr>
-              <a:t>次へ進む前の確認　□ 入力→処理→出力と、「先行にないところ」を指差せる</a:t>
+              <a:t>次へ進む前の確認　□ 入力→処理→出力と、「先行特許にないところ」を指差せる</a:t>
             </a:r>
           </a:p>
         </p:txBody>
@@ -18442,7 +18442,7 @@
                 </a:solidFill>
                 <a:latin typeface="Noto Sans CJK JP"/>
               </a:rPr>
-              <a:t>やること 1　Step 1で見た先行を踏まえる</a:t>
+              <a:t>やること 1　Step 1で見た先行特許を踏まえる</a:t>
             </a:r>
           </a:p>
         </p:txBody>
@@ -18602,7 +18602,7 @@
                 </a:solidFill>
                 <a:latin typeface="Noto Sans CJK JP"/>
               </a:rPr>
-              <a:t>やること 3　先行にないところだけ厚くする</a:t>
+              <a:t>やること 3　先行特許にないところだけ厚くする</a:t>
             </a:r>
           </a:p>
         </p:txBody>
@@ -18767,7 +18767,7 @@
                 </a:solidFill>
                 <a:latin typeface="Noto Sans CJK JP"/>
               </a:rPr>
-              <a:t>先行にはルールベースのロジック自動生成があります。本発明の違いを、システム構成と処理の流れで具体化してください。人が確認する点も残してください。</a:t>
+              <a:t>先行特許にはルールベースのロジック自動生成があります。本発明の違いを、システム構成と処理の流れで具体化してください。人が確認する点も残してください。</a:t>
             </a:r>
           </a:p>
         </p:txBody>
@@ -18887,7 +18887,7 @@
                 </a:solidFill>
                 <a:latin typeface="Noto Sans CJK JP"/>
               </a:rPr>
-              <a:t>先行の『ルールでロジックを自動生成する』は残しつつ、本発明が厚いところ（検証と追跡）を構成と流れで書きます。ここが後の差の表とクレームの材料になります。</a:t>
+              <a:t>先行特許の『ルールでロジックを自動生成する』は残しつつ、本発明が厚いところ（検証と追跡）を構成と流れで書きます。ここが後の差の表とクレームの材料になります。</a:t>
             </a:r>
           </a:p>
           <a:p>
@@ -18944,7 +18944,7 @@
                 </a:solidFill>
                 <a:latin typeface="Noto Sans CJK JP"/>
               </a:rPr>
-              <a:t>■ 先行との差（厚く書くところ）　先行は生成までが多い。本発明は検証結果を設計成果物へ戻し、HAZOPの原因−SIF−素子の対応を残す。自動生成そのものは差になりにくいので、ここを具体例つきで書いてください。</a:t>
+              <a:t>■ 先行特許との差（厚く書くところ）　先行特許は生成までが多い。本発明は検証結果を設計成果物へ戻し、HAZOPの原因−SIF−素子の対応を残す。自動生成そのものは差になりにくいので、ここを具体例つきで書いてください。</a:t>
             </a:r>
           </a:p>
           <a:p>

</xml_diff>

<commit_message>
Treat Copilot as the first prior-patent search tool
PatentSQUARE is now an optional in-house tool for later, not a required
first step. Beginners start prior-art search in Copilot.

Co-authored-by: zhexingwang <zhexingwang@users.noreply.github.com>
</commit_message>
<xml_diff>
--- a/decks/05_Copilot発明開示書/Copilot発明開示書_訂正反映.pptx
+++ b/decks/05_Copilot発明開示書/Copilot発明開示書_訂正反映.pptx
@@ -10219,7 +10219,7 @@
                 </a:solidFill>
                 <a:latin typeface="Noto Sans CJK JP"/>
               </a:rPr>
-              <a:t>使う道具は2つ</a:t>
+              <a:t>使う道具</a:t>
             </a:r>
           </a:p>
         </p:txBody>
@@ -10254,7 +10254,7 @@
                 </a:solidFill>
                 <a:latin typeface="Noto Sans CJK JP"/>
               </a:rPr>
-              <a:t>文章づくりと、近い先行特許を探すこと</a:t>
+              <a:t>まずはCopilot。先行特許の調査も、最初はここでよい</a:t>
             </a:r>
           </a:p>
         </p:txBody>
@@ -10267,8 +10267,8 @@
         </p:nvSpPr>
         <p:spPr>
           <a:xfrm>
-            <a:off x="502920" y="1417320"/>
-            <a:ext cx="5532120" cy="4206240"/>
+            <a:off x="457200" y="1325880"/>
+            <a:ext cx="7360920" cy="4892040"/>
           </a:xfrm>
           <a:prstGeom prst="roundRect">
             <a:avLst>
@@ -10312,8 +10312,8 @@
         </p:nvSpPr>
         <p:spPr>
           <a:xfrm>
-            <a:off x="502920" y="1417320"/>
-            <a:ext cx="5532120" cy="777240"/>
+            <a:off x="457200" y="1325880"/>
+            <a:ext cx="7360920" cy="777240"/>
           </a:xfrm>
           <a:prstGeom prst="rect">
             <a:avLst/>
@@ -10355,8 +10355,8 @@
         </p:nvSpPr>
         <p:spPr>
           <a:xfrm>
-            <a:off x="502920" y="1554480"/>
-            <a:ext cx="5532120" cy="502920"/>
+            <a:off x="457200" y="1444752"/>
+            <a:ext cx="7360920" cy="530352"/>
           </a:xfrm>
           <a:prstGeom prst="rect">
             <a:avLst/>
@@ -10377,7 +10377,7 @@
                 </a:solidFill>
                 <a:latin typeface="Noto Sans CJK JP"/>
               </a:rPr>
-              <a:t>M365 Copilot</a:t>
+              <a:t>まずはこれ　M365 Copilot</a:t>
             </a:r>
           </a:p>
         </p:txBody>
@@ -10390,8 +10390,8 @@
         </p:nvSpPr>
         <p:spPr>
           <a:xfrm>
-            <a:off x="868680" y="2560320"/>
-            <a:ext cx="4800600" cy="2560320"/>
+            <a:off x="777240" y="2331720"/>
+            <a:ext cx="6720840" cy="3520440"/>
           </a:xfrm>
           <a:prstGeom prst="rect">
             <a:avLst/>
@@ -10406,14 +10406,17 @@
           <a:p>
             <a:pPr algn="l"/>
             <a:r>
-              <a:rPr sz="1800" b="0">
+              <a:rPr sz="1600" b="0">
                 <a:solidFill>
                   <a:srgbClr val="2D2D2D"/>
                 </a:solidFill>
                 <a:latin typeface="Noto Sans CJK JP"/>
               </a:rPr>
-              <a:t>文章の下書き・整理・用語そろえ
-自然な言葉で依頼する</a:t>
+              <a:t>・文章の下書き・整理・用語そろえ
+・近い先行特許の見当をつける（キーワード、似ている点／違う点）
+・自然な言葉で依頼する
+クレームを書く前に、近い先行特許を見る。
+その調査も、最初はCopilotでよい。</a:t>
             </a:r>
           </a:p>
         </p:txBody>
@@ -10426,8 +10429,8 @@
         </p:nvSpPr>
         <p:spPr>
           <a:xfrm>
-            <a:off x="6263640" y="1417320"/>
-            <a:ext cx="5532120" cy="4206240"/>
+            <a:off x="8001000" y="1325880"/>
+            <a:ext cx="3703320" cy="4892040"/>
           </a:xfrm>
           <a:prstGeom prst="roundRect">
             <a:avLst>
@@ -10471,14 +10474,14 @@
         </p:nvSpPr>
         <p:spPr>
           <a:xfrm>
-            <a:off x="6263640" y="1417320"/>
-            <a:ext cx="5532120" cy="777240"/>
+            <a:off x="8001000" y="1325880"/>
+            <a:ext cx="3703320" cy="777240"/>
           </a:xfrm>
           <a:prstGeom prst="rect">
             <a:avLst/>
           </a:prstGeom>
           <a:solidFill>
-            <a:srgbClr val="ED7D31"/>
+            <a:srgbClr val="2E75B6"/>
           </a:solidFill>
           <a:ln>
             <a:noFill/>
@@ -10514,8 +10517,8 @@
         </p:nvSpPr>
         <p:spPr>
           <a:xfrm>
-            <a:off x="6263640" y="1554480"/>
-            <a:ext cx="5532120" cy="502920"/>
+            <a:off x="8001000" y="1389888"/>
+            <a:ext cx="3703320" cy="292608"/>
           </a:xfrm>
           <a:prstGeom prst="rect">
             <a:avLst/>
@@ -10530,12 +10533,47 @@
           <a:p>
             <a:pPr algn="ctr"/>
             <a:r>
-              <a:rPr sz="2200" b="1">
+              <a:rPr sz="1200" b="1">
                 <a:solidFill>
                   <a:srgbClr val="FFFFFF"/>
                 </a:solidFill>
                 <a:latin typeface="Noto Sans CJK JP"/>
               </a:rPr>
+              <a:t>社内ツール　上級者向け</a:t>
+            </a:r>
+          </a:p>
+        </p:txBody>
+      </p:sp>
+      <p:sp>
+        <p:nvSpPr>
+          <p:cNvPr id="12" name="TextBox 11"/>
+          <p:cNvSpPr txBox="1"/>
+          <p:nvPr/>
+        </p:nvSpPr>
+        <p:spPr>
+          <a:xfrm>
+            <a:off x="8001000" y="1664208"/>
+            <a:ext cx="3703320" cy="365760"/>
+          </a:xfrm>
+          <a:prstGeom prst="rect">
+            <a:avLst/>
+          </a:prstGeom>
+          <a:noFill/>
+        </p:spPr>
+        <p:txBody>
+          <a:bodyPr wrap="square" anchor="t">
+            <a:spAutoFit/>
+          </a:bodyPr>
+          <a:lstStyle/>
+          <a:p>
+            <a:pPr algn="ctr"/>
+            <a:r>
+              <a:rPr sz="1800" b="1">
+                <a:solidFill>
+                  <a:srgbClr val="FFFFFF"/>
+                </a:solidFill>
+                <a:latin typeface="Noto Sans CJK JP"/>
+              </a:rPr>
               <a:t>PatentSQUARE</a:t>
             </a:r>
           </a:p>
@@ -10543,14 +10581,14 @@
       </p:sp>
       <p:sp>
         <p:nvSpPr>
-          <p:cNvPr id="12" name="TextBox 11"/>
-          <p:cNvSpPr txBox="1"/>
-          <p:nvPr/>
-        </p:nvSpPr>
-        <p:spPr>
-          <a:xfrm>
-            <a:off x="6629400" y="2560320"/>
-            <a:ext cx="4800600" cy="2560320"/>
+          <p:cNvPr id="13" name="TextBox 12"/>
+          <p:cNvSpPr txBox="1"/>
+          <p:nvPr/>
+        </p:nvSpPr>
+        <p:spPr>
+          <a:xfrm>
+            <a:off x="8229600" y="2331720"/>
+            <a:ext cx="3246120" cy="3520440"/>
           </a:xfrm>
           <a:prstGeom prst="rect">
             <a:avLst/>
@@ -10565,21 +10603,22 @@
           <a:p>
             <a:pPr algn="l"/>
             <a:r>
-              <a:rPr sz="1800" b="0">
+              <a:rPr sz="1500" b="0">
                 <a:solidFill>
                   <a:srgbClr val="2D2D2D"/>
                 </a:solidFill>
                 <a:latin typeface="Noto Sans CJK JP"/>
               </a:rPr>
-              <a:t>近い先行特許を探す（社内標準）
-クレームを書く前に使う</a:t>
-            </a:r>
-          </a:p>
-        </p:txBody>
-      </p:sp>
-      <p:sp>
-        <p:nvSpPr>
-          <p:cNvPr id="13" name="TextBox 12"/>
+              <a:t>特許を本格的に探す、社内の仕組みです。
+最初は使わなくてよい。
+慣れてきたら使うと、調査がより確かになる。</a:t>
+            </a:r>
+          </a:p>
+        </p:txBody>
+      </p:sp>
+      <p:sp>
+        <p:nvSpPr>
+          <p:cNvPr id="14" name="TextBox 13"/>
           <p:cNvSpPr txBox="1"/>
           <p:nvPr/>
         </p:nvSpPr>
@@ -10614,7 +10653,7 @@
       </p:sp>
       <p:sp>
         <p:nvSpPr>
-          <p:cNvPr id="14" name="TextBox 13"/>
+          <p:cNvPr id="15" name="TextBox 14"/>
           <p:cNvSpPr txBox="1"/>
           <p:nvPr/>
         </p:nvSpPr>
@@ -16969,7 +17008,7 @@
                 </a:solidFill>
                 <a:latin typeface="Noto Sans CJK JP"/>
               </a:rPr>
-              <a:t>やること 1　PatentSQUAREで類似を探す</a:t>
+              <a:t>やること 1　Copilotで近い先行特許を聞く</a:t>
             </a:r>
           </a:p>
         </p:txBody>
@@ -17049,7 +17088,7 @@
                 </a:solidFill>
                 <a:latin typeface="Noto Sans CJK JP"/>
               </a:rPr>
-              <a:t>やること 2　ヒットの要約をAIに渡す</a:t>
+              <a:t>やること 2　似ている点／違う点を整理する</a:t>
             </a:r>
           </a:p>
         </p:txBody>
@@ -17414,7 +17453,7 @@
                 </a:solidFill>
                 <a:latin typeface="Noto Sans CJK JP"/>
               </a:rPr>
-              <a:t>了解です。クレームは書きません。先に『何が近いか』を見るための検索語と、読むときの観点だけ出します。PatentSQUARE（社内標準）で試し、ヒットの要約をまた貼ってください。</a:t>
+              <a:t>了解です。クレームは書きません。先に『何が近いか』を見るための検索語と、読むときの観点だけ出します。まずはCopilotにこのまま聞いて、近い特許の見当をつけてください。社内にはPatentSQUAREという本格的な特許検索もあります。上級者向けなので、最初は使わなくてよいです。慣れたらそこで確認すると、調査がより確かになります。</a:t>
             </a:r>
           </a:p>
           <a:p>

</xml_diff>